<commit_message>
docs: add architecture documentation and update project presentation files
</commit_message>
<xml_diff>
--- a/T9998_VIT-Chennai_Rahi_Sanxipt_Mehta_Review1.pptx
+++ b/T9998_VIT-Chennai_Rahi_Sanxipt_Mehta_Review1.pptx
@@ -9,11 +9,12 @@
     <p:sldId id="2147470492" r:id="rId3"/>
     <p:sldId id="2147470493" r:id="rId4"/>
     <p:sldId id="2147470494" r:id="rId5"/>
-    <p:sldId id="2147470495" r:id="rId6"/>
+    <p:sldId id="2147470498" r:id="rId6"/>
     <p:sldId id="2147470496" r:id="rId7"/>
     <p:sldId id="2147470497" r:id="rId8"/>
     <p:sldId id="2147470491" r:id="rId9"/>
     <p:sldId id="2147470487" r:id="rId10"/>
+    <p:sldId id="261" r:id="rId11"/>
   </p:sldIdLst>
   <p:sldSz cx="12192000" cy="6858000"/>
   <p:notesSz cx="6858000" cy="9144000"/>
@@ -3996,6 +3997,131 @@
 </p:sld>
 </file>
 
+<file path=ppt/slides/slide10.xml><?xml version="1.0" encoding="utf-8"?>
+<p:sld xmlns:a="http://schemas.openxmlformats.org/drawingml/2006/main" xmlns:r="http://schemas.openxmlformats.org/officeDocument/2006/relationships" xmlns:p="http://schemas.openxmlformats.org/presentationml/2006/main">
+  <p:cSld>
+    <p:spTree>
+      <p:nvGrpSpPr>
+        <p:cNvPr id="1" name=""/>
+        <p:cNvGrpSpPr/>
+        <p:nvPr/>
+      </p:nvGrpSpPr>
+      <p:grpSpPr>
+        <a:xfrm>
+          <a:off x="0" y="0"/>
+          <a:ext cx="0" cy="0"/>
+          <a:chOff x="0" y="0"/>
+          <a:chExt cx="0" cy="0"/>
+        </a:xfrm>
+      </p:grpSpPr>
+      <p:sp>
+        <p:nvSpPr>
+          <p:cNvPr id="2" name="Freeform 2"/>
+          <p:cNvSpPr/>
+          <p:nvPr/>
+        </p:nvSpPr>
+        <p:spPr>
+          <a:xfrm>
+            <a:off x="-613279" y="1863675"/>
+            <a:ext cx="13418557" cy="7441200"/>
+          </a:xfrm>
+          <a:custGeom>
+            <a:avLst/>
+            <a:gdLst/>
+            <a:ahLst/>
+            <a:cxnLst/>
+            <a:rect l="l" t="t" r="r" b="b"/>
+            <a:pathLst>
+              <a:path w="20127836" h="11161800">
+                <a:moveTo>
+                  <a:pt x="0" y="0"/>
+                </a:moveTo>
+                <a:lnTo>
+                  <a:pt x="20127836" y="0"/>
+                </a:lnTo>
+                <a:lnTo>
+                  <a:pt x="20127836" y="11161800"/>
+                </a:lnTo>
+                <a:lnTo>
+                  <a:pt x="0" y="11161800"/>
+                </a:lnTo>
+                <a:lnTo>
+                  <a:pt x="0" y="0"/>
+                </a:lnTo>
+                <a:close/>
+              </a:path>
+            </a:pathLst>
+          </a:custGeom>
+          <a:blipFill>
+            <a:blip>
+              <a:extLst>
+                <a:ext uri="{96DAC541-7B7A-43D3-8B79-37D633B846F1}">
+                  <asvg:svgBlip xmlns:asvg="http://schemas.microsoft.com/office/drawing/2016/SVG/main" r:embed="rId2"/>
+                </a:ext>
+              </a:extLst>
+            </a:blip>
+            <a:stretch>
+              <a:fillRect/>
+            </a:stretch>
+          </a:blipFill>
+        </p:spPr>
+        <p:txBody>
+          <a:bodyPr/>
+          <a:lstStyle/>
+          <a:p>
+            <a:endParaRPr lang="en-IN" sz="1200"/>
+          </a:p>
+        </p:txBody>
+      </p:sp>
+      <p:sp>
+        <p:nvSpPr>
+          <p:cNvPr id="3" name="TextBox 3"/>
+          <p:cNvSpPr txBox="1"/>
+          <p:nvPr/>
+        </p:nvSpPr>
+        <p:spPr>
+          <a:xfrm>
+            <a:off x="1992147" y="1761097"/>
+            <a:ext cx="8207706" cy="1752724"/>
+          </a:xfrm>
+          <a:prstGeom prst="rect">
+            <a:avLst/>
+          </a:prstGeom>
+        </p:spPr>
+        <p:txBody>
+          <a:bodyPr lIns="0" tIns="0" rIns="0" bIns="0" rtlCol="0" anchor="t">
+            <a:spAutoFit/>
+          </a:bodyPr>
+          <a:lstStyle/>
+          <a:p>
+            <a:pPr algn="ctr">
+              <a:lnSpc>
+                <a:spcPts val="14967"/>
+              </a:lnSpc>
+            </a:pPr>
+            <a:r>
+              <a:rPr lang="en-US" sz="10615" b="1" dirty="0">
+                <a:solidFill>
+                  <a:srgbClr val="1C1C1C"/>
+                </a:solidFill>
+                <a:latin typeface="Montserrat Bold"/>
+                <a:ea typeface="Montserrat Bold"/>
+                <a:cs typeface="Montserrat Bold"/>
+                <a:sym typeface="Montserrat Bold"/>
+              </a:rPr>
+              <a:t>Thank You</a:t>
+            </a:r>
+          </a:p>
+        </p:txBody>
+      </p:sp>
+    </p:spTree>
+  </p:cSld>
+  <p:clrMapOvr>
+    <a:masterClrMapping/>
+  </p:clrMapOvr>
+</p:sld>
+</file>
+
 <file path=ppt/slides/slide2.xml><?xml version="1.0" encoding="utf-8"?>
 <p:sld xmlns:a="http://schemas.openxmlformats.org/drawingml/2006/main" xmlns:r="http://schemas.openxmlformats.org/officeDocument/2006/relationships" xmlns:p="http://schemas.openxmlformats.org/presentationml/2006/main">
   <p:cSld>
@@ -4689,10 +4815,10 @@
       </p:cxnSp>
       <p:sp>
         <p:nvSpPr>
-          <p:cNvPr id="4" name="TextBox 3">
+          <p:cNvPr id="9" name="TextBox 8">
             <a:extLst>
               <a:ext uri="{FF2B5EF4-FFF2-40B4-BE49-F238E27FC236}">
-                <a16:creationId xmlns:a16="http://schemas.microsoft.com/office/drawing/2014/main" id="{E4452DD5-D934-4955-F39B-2109AC72692F}"/>
+                <a16:creationId xmlns:a16="http://schemas.microsoft.com/office/drawing/2014/main" id="{19D4532F-D1AA-E8F5-291C-8A9D0DF14799}"/>
               </a:ext>
             </a:extLst>
           </p:cNvPr>
@@ -4701,8 +4827,8 @@
         </p:nvSpPr>
         <p:spPr>
           <a:xfrm>
-            <a:off x="6093893" y="57036"/>
-            <a:ext cx="6098107" cy="646331"/>
+            <a:off x="2792361" y="57036"/>
+            <a:ext cx="9399640" cy="369332"/>
           </a:xfrm>
           <a:prstGeom prst="rect">
             <a:avLst/>
@@ -4717,16 +4843,13 @@
           <a:p>
             <a:pPr algn="r"/>
             <a:r>
-              <a:rPr lang="en-US" sz="1800" b="1" i="1" dirty="0">
+              <a:rPr lang="en-GB" b="1" i="1" dirty="0">
                 <a:solidFill>
                   <a:srgbClr val="FFFFFF"/>
                 </a:solidFill>
               </a:rPr>
-              <a:t>Project Title -  Calibri body 18</a:t>
-            </a:r>
-          </a:p>
-          <a:p>
-            <a:pPr algn="r"/>
+              <a:t>AccessGov: An AI-Powered Assistive Platform for Accessing and Navigating Government Services</a:t>
+            </a:r>
             <a:endParaRPr lang="en-US" dirty="0"/>
           </a:p>
         </p:txBody>
@@ -5227,10 +5350,10 @@
       </p:cxnSp>
       <p:sp>
         <p:nvSpPr>
-          <p:cNvPr id="4" name="TextBox 3">
+          <p:cNvPr id="7" name="TextBox 6">
             <a:extLst>
               <a:ext uri="{FF2B5EF4-FFF2-40B4-BE49-F238E27FC236}">
-                <a16:creationId xmlns:a16="http://schemas.microsoft.com/office/drawing/2014/main" id="{6CE164B1-01DD-BF3B-88E8-DF2DEDBFA9EB}"/>
+                <a16:creationId xmlns:a16="http://schemas.microsoft.com/office/drawing/2014/main" id="{34C21C24-4796-2D5E-0483-49ACD14B8DC2}"/>
               </a:ext>
             </a:extLst>
           </p:cNvPr>
@@ -5239,8 +5362,8 @@
         </p:nvSpPr>
         <p:spPr>
           <a:xfrm>
-            <a:off x="6093893" y="57036"/>
-            <a:ext cx="6098107" cy="646331"/>
+            <a:off x="2792361" y="57036"/>
+            <a:ext cx="9399640" cy="369332"/>
           </a:xfrm>
           <a:prstGeom prst="rect">
             <a:avLst/>
@@ -5255,16 +5378,13 @@
           <a:p>
             <a:pPr algn="r"/>
             <a:r>
-              <a:rPr lang="en-US" sz="1800" b="1" i="1" dirty="0">
+              <a:rPr lang="en-GB" b="1" i="1" dirty="0">
                 <a:solidFill>
                   <a:srgbClr val="FFFFFF"/>
                 </a:solidFill>
               </a:rPr>
-              <a:t>Project Title -  Calibri body 18</a:t>
-            </a:r>
-          </a:p>
-          <a:p>
-            <a:pPr algn="r"/>
+              <a:t>AccessGov: An AI-Powered Assistive Platform for Accessing and Navigating Government Services</a:t>
+            </a:r>
             <a:endParaRPr lang="en-US" dirty="0"/>
           </a:p>
         </p:txBody>
@@ -5499,140 +5619,6 @@
       </p:grpSpPr>
       <p:sp>
         <p:nvSpPr>
-          <p:cNvPr id="2" name="Text Placeholder 1">
-            <a:extLst>
-              <a:ext uri="{FF2B5EF4-FFF2-40B4-BE49-F238E27FC236}">
-                <a16:creationId xmlns:a16="http://schemas.microsoft.com/office/drawing/2014/main" id="{DB433ECB-8EAD-0AB5-1D66-62BCF658AA2C}"/>
-              </a:ext>
-            </a:extLst>
-          </p:cNvPr>
-          <p:cNvSpPr>
-            <a:spLocks noGrp="1"/>
-          </p:cNvSpPr>
-          <p:nvPr>
-            <p:ph type="body" sz="quarter" idx="13"/>
-          </p:nvPr>
-        </p:nvSpPr>
-        <p:spPr>
-          <a:xfrm>
-            <a:off x="255996" y="1271219"/>
-            <a:ext cx="10624338" cy="4142989"/>
-          </a:xfrm>
-        </p:spPr>
-        <p:txBody>
-          <a:bodyPr/>
-          <a:lstStyle/>
-          <a:p>
-            <a:pPr>
-              <a:lnSpc>
-                <a:spcPct val="100000"/>
-              </a:lnSpc>
-            </a:pPr>
-            <a:r>
-              <a:rPr lang="en-US" dirty="0">
-                <a:solidFill>
-                  <a:srgbClr val="5583D1"/>
-                </a:solidFill>
-                <a:latin typeface="+mn-lt"/>
-              </a:rPr>
-              <a:t>Existing Portals:</a:t>
-            </a:r>
-            <a:r>
-              <a:rPr lang="en-US" b="0" dirty="0">
-                <a:solidFill>
-                  <a:srgbClr val="5583D1"/>
-                </a:solidFill>
-                <a:latin typeface="+mn-lt"/>
-              </a:rPr>
-              <a:t> Current e-governance portals rely on rigid keyword searches and fragmented PDFs, making discovery difficult. </a:t>
-            </a:r>
-          </a:p>
-          <a:p>
-            <a:pPr>
-              <a:lnSpc>
-                <a:spcPct val="100000"/>
-              </a:lnSpc>
-            </a:pPr>
-            <a:r>
-              <a:rPr lang="en-US" dirty="0">
-                <a:solidFill>
-                  <a:srgbClr val="5583D1"/>
-                </a:solidFill>
-                <a:latin typeface="+mn-lt"/>
-              </a:rPr>
-              <a:t>RAG in Legal/Bureaucratic Contexts: </a:t>
-            </a:r>
-            <a:r>
-              <a:rPr lang="en-US" b="0" dirty="0">
-                <a:solidFill>
-                  <a:srgbClr val="5583D1"/>
-                </a:solidFill>
-                <a:latin typeface="+mn-lt"/>
-              </a:rPr>
-              <a:t>Recent implementations of Retrieval-Augmented Generation (RAG) show high accuracy in parsing complex domain-specific documents (e.g., PyMuPDF + LangChain). </a:t>
-            </a:r>
-          </a:p>
-          <a:p>
-            <a:pPr>
-              <a:lnSpc>
-                <a:spcPct val="100000"/>
-              </a:lnSpc>
-            </a:pPr>
-            <a:r>
-              <a:rPr lang="en-US" b="0" dirty="0">
-                <a:solidFill>
-                  <a:srgbClr val="5583D1"/>
-                </a:solidFill>
-                <a:latin typeface="+mn-lt"/>
-              </a:rPr>
-              <a:t>L</a:t>
-            </a:r>
-            <a:r>
-              <a:rPr lang="en-US" dirty="0">
-                <a:solidFill>
-                  <a:srgbClr val="5583D1"/>
-                </a:solidFill>
-                <a:latin typeface="+mn-lt"/>
-              </a:rPr>
-              <a:t>LM Simplification:</a:t>
-            </a:r>
-            <a:r>
-              <a:rPr lang="en-US" b="0" dirty="0">
-                <a:solidFill>
-                  <a:srgbClr val="5583D1"/>
-                </a:solidFill>
-                <a:latin typeface="+mn-lt"/>
-              </a:rPr>
-              <a:t> Open-source models like </a:t>
-            </a:r>
-            <a:r>
-              <a:rPr lang="en-US" b="0" dirty="0" err="1">
-                <a:solidFill>
-                  <a:srgbClr val="5583D1"/>
-                </a:solidFill>
-                <a:latin typeface="+mn-lt"/>
-              </a:rPr>
-              <a:t>LLaMA</a:t>
-            </a:r>
-            <a:r>
-              <a:rPr lang="en-US" b="0" dirty="0">
-                <a:solidFill>
-                  <a:srgbClr val="5583D1"/>
-                </a:solidFill>
-                <a:latin typeface="+mn-lt"/>
-              </a:rPr>
-              <a:t> 3 effectively summarize and simplify dense jargon into plain language.</a:t>
-            </a:r>
-            <a:endParaRPr lang="en-US" b="0" dirty="0">
-              <a:solidFill>
-                <a:srgbClr val="5583D1"/>
-              </a:solidFill>
-            </a:endParaRPr>
-          </a:p>
-        </p:txBody>
-      </p:sp>
-      <p:sp>
-        <p:nvSpPr>
           <p:cNvPr id="3" name="TextBox 2">
             <a:extLst>
               <a:ext uri="{FF2B5EF4-FFF2-40B4-BE49-F238E27FC236}">
@@ -5741,12 +5727,279 @@
           </a:fontRef>
         </p:style>
       </p:cxnSp>
+      <p:graphicFrame>
+        <p:nvGraphicFramePr>
+          <p:cNvPr id="7" name="Table 6">
+            <a:extLst>
+              <a:ext uri="{FF2B5EF4-FFF2-40B4-BE49-F238E27FC236}">
+                <a16:creationId xmlns:a16="http://schemas.microsoft.com/office/drawing/2014/main" id="{82763BE9-FEFC-27A8-4FFA-56D3AB575F5A}"/>
+              </a:ext>
+            </a:extLst>
+          </p:cNvPr>
+          <p:cNvGraphicFramePr>
+            <a:graphicFrameLocks noGrp="1"/>
+          </p:cNvGraphicFramePr>
+          <p:nvPr>
+            <p:extLst>
+              <p:ext uri="{D42A27DB-BD31-4B8C-83A1-F6EECF244321}">
+                <p14:modId xmlns:p14="http://schemas.microsoft.com/office/powerpoint/2010/main" val="1542304720"/>
+              </p:ext>
+            </p:extLst>
+          </p:nvPr>
+        </p:nvGraphicFramePr>
+        <p:xfrm>
+          <a:off x="221274" y="1329266"/>
+          <a:ext cx="11744584" cy="4297680"/>
+        </p:xfrm>
+        <a:graphic>
+          <a:graphicData uri="http://schemas.openxmlformats.org/drawingml/2006/table">
+            <a:tbl>
+              <a:tblPr firstRow="1" bandRow="1">
+                <a:tableStyleId>{5C22544A-7EE6-4342-B048-85BDC9FD1C3A}</a:tableStyleId>
+              </a:tblPr>
+              <a:tblGrid>
+                <a:gridCol w="5872292">
+                  <a:extLst>
+                    <a:ext uri="{9D8B030D-6E8A-4147-A177-3AD203B41FA5}">
+                      <a16:colId xmlns:a16="http://schemas.microsoft.com/office/drawing/2014/main" val="4252064122"/>
+                    </a:ext>
+                  </a:extLst>
+                </a:gridCol>
+                <a:gridCol w="5872292">
+                  <a:extLst>
+                    <a:ext uri="{9D8B030D-6E8A-4147-A177-3AD203B41FA5}">
+                      <a16:colId xmlns:a16="http://schemas.microsoft.com/office/drawing/2014/main" val="1458741793"/>
+                    </a:ext>
+                  </a:extLst>
+                </a:gridCol>
+              </a:tblGrid>
+              <a:tr h="370840">
+                <a:tc>
+                  <a:txBody>
+                    <a:bodyPr/>
+                    <a:lstStyle/>
+                    <a:p>
+                      <a:pPr algn="ctr"/>
+                      <a:r>
+                        <a:rPr lang="en-IN" sz="3600" b="1" i="0" kern="1200" dirty="0">
+                          <a:solidFill>
+                            <a:schemeClr val="lt1"/>
+                          </a:solidFill>
+                          <a:effectLst/>
+                          <a:latin typeface="+mn-lt"/>
+                          <a:ea typeface="+mn-ea"/>
+                          <a:cs typeface="+mn-cs"/>
+                        </a:rPr>
+                        <a:t>Paper </a:t>
+                      </a:r>
+                      <a:endParaRPr lang="en-IN" i="0" dirty="0"/>
+                    </a:p>
+                  </a:txBody>
+                  <a:tcPr/>
+                </a:tc>
+                <a:tc>
+                  <a:txBody>
+                    <a:bodyPr/>
+                    <a:lstStyle/>
+                    <a:p>
+                      <a:pPr algn="ctr"/>
+                      <a:r>
+                        <a:rPr lang="en-IN" sz="3600" b="1" i="0" kern="1200" dirty="0">
+                          <a:solidFill>
+                            <a:schemeClr val="lt1"/>
+                          </a:solidFill>
+                          <a:effectLst/>
+                          <a:latin typeface="+mn-lt"/>
+                          <a:ea typeface="+mn-ea"/>
+                          <a:cs typeface="+mn-cs"/>
+                        </a:rPr>
+                        <a:t>Summary</a:t>
+                      </a:r>
+                      <a:endParaRPr lang="en-IN" i="0" dirty="0"/>
+                    </a:p>
+                  </a:txBody>
+                  <a:tcPr/>
+                </a:tc>
+                <a:extLst>
+                  <a:ext uri="{0D108BD9-81ED-4DB2-BD59-A6C34878D82A}">
+                    <a16:rowId xmlns:a16="http://schemas.microsoft.com/office/drawing/2014/main" val="3834261949"/>
+                  </a:ext>
+                </a:extLst>
+              </a:tr>
+              <a:tr h="370840">
+                <a:tc>
+                  <a:txBody>
+                    <a:bodyPr/>
+                    <a:lstStyle/>
+                    <a:p>
+                      <a:r>
+                        <a:rPr lang="en-GB" sz="1800" i="0" dirty="0"/>
+                        <a:t>Bridging Citizens and Public Services with RAG (2026)</a:t>
+                      </a:r>
+                      <a:endParaRPr lang="en-IN" sz="1800" i="0" dirty="0"/>
+                    </a:p>
+                  </a:txBody>
+                  <a:tcPr/>
+                </a:tc>
+                <a:tc>
+                  <a:txBody>
+                    <a:bodyPr/>
+                    <a:lstStyle/>
+                    <a:p>
+                      <a:r>
+                        <a:rPr lang="en-GB" sz="1800" i="0" dirty="0"/>
+                        <a:t>Proves that RAG can successfully associate natural language citizen queries with complex bureaucratic services, improving portal accessibility.</a:t>
+                      </a:r>
+                      <a:endParaRPr lang="en-IN" sz="1800" i="0" dirty="0"/>
+                    </a:p>
+                  </a:txBody>
+                  <a:tcPr/>
+                </a:tc>
+                <a:extLst>
+                  <a:ext uri="{0D108BD9-81ED-4DB2-BD59-A6C34878D82A}">
+                    <a16:rowId xmlns:a16="http://schemas.microsoft.com/office/drawing/2014/main" val="1809544936"/>
+                  </a:ext>
+                </a:extLst>
+              </a:tr>
+              <a:tr h="370840">
+                <a:tc>
+                  <a:txBody>
+                    <a:bodyPr/>
+                    <a:lstStyle/>
+                    <a:p>
+                      <a:r>
+                        <a:rPr lang="en-IN" sz="1800" b="0" i="0" kern="1200" dirty="0">
+                          <a:solidFill>
+                            <a:schemeClr val="dk1"/>
+                          </a:solidFill>
+                          <a:effectLst/>
+                          <a:latin typeface="+mn-lt"/>
+                          <a:ea typeface="+mn-ea"/>
+                          <a:cs typeface="+mn-cs"/>
+                        </a:rPr>
+                        <a:t>Retrieval-Augmented Governance (2025)</a:t>
+                      </a:r>
+                      <a:endParaRPr lang="en-IN" sz="1800" i="0" dirty="0"/>
+                    </a:p>
+                  </a:txBody>
+                  <a:tcPr/>
+                </a:tc>
+                <a:tc>
+                  <a:txBody>
+                    <a:bodyPr/>
+                    <a:lstStyle/>
+                    <a:p>
+                      <a:r>
+                        <a:rPr lang="en-IN" sz="1800" b="0" i="0" kern="1200" dirty="0">
+                          <a:solidFill>
+                            <a:schemeClr val="dk1"/>
+                          </a:solidFill>
+                          <a:effectLst/>
+                          <a:latin typeface="+mn-lt"/>
+                          <a:ea typeface="+mn-ea"/>
+                          <a:cs typeface="+mn-cs"/>
+                        </a:rPr>
+                        <a:t>Highlights the need for "governance-by-design" by integrating strict audit trails and source validation to ensure AI explanations are verifiable.</a:t>
+                      </a:r>
+                      <a:endParaRPr lang="en-IN" sz="1800" i="0" dirty="0"/>
+                    </a:p>
+                  </a:txBody>
+                  <a:tcPr/>
+                </a:tc>
+                <a:extLst>
+                  <a:ext uri="{0D108BD9-81ED-4DB2-BD59-A6C34878D82A}">
+                    <a16:rowId xmlns:a16="http://schemas.microsoft.com/office/drawing/2014/main" val="2557124098"/>
+                  </a:ext>
+                </a:extLst>
+              </a:tr>
+              <a:tr h="370840">
+                <a:tc>
+                  <a:txBody>
+                    <a:bodyPr/>
+                    <a:lstStyle/>
+                    <a:p>
+                      <a:r>
+                        <a:rPr lang="en-GB" sz="1800" b="0" i="0" kern="1200" dirty="0">
+                          <a:solidFill>
+                            <a:schemeClr val="dk1"/>
+                          </a:solidFill>
+                          <a:effectLst/>
+                          <a:latin typeface="+mn-lt"/>
+                          <a:ea typeface="+mn-ea"/>
+                          <a:cs typeface="+mn-cs"/>
+                        </a:rPr>
+                        <a:t>Evaluating Faithfulness in Agentic RAG Systems for e-Governance (2025):</a:t>
+                      </a:r>
+                      <a:endParaRPr lang="en-IN" sz="1800" i="0" dirty="0"/>
+                    </a:p>
+                  </a:txBody>
+                  <a:tcPr/>
+                </a:tc>
+                <a:tc>
+                  <a:txBody>
+                    <a:bodyPr/>
+                    <a:lstStyle/>
+                    <a:p>
+                      <a:r>
+                        <a:rPr lang="en-GB" sz="1800" i="0" dirty="0"/>
+                        <a:t>Emphasizes hallucination mitigation in high-stakes government applications by using Agentic models and rigorous evaluation frameworks.</a:t>
+                      </a:r>
+                      <a:endParaRPr lang="en-IN" sz="1800" i="0" dirty="0"/>
+                    </a:p>
+                  </a:txBody>
+                  <a:tcPr/>
+                </a:tc>
+                <a:extLst>
+                  <a:ext uri="{0D108BD9-81ED-4DB2-BD59-A6C34878D82A}">
+                    <a16:rowId xmlns:a16="http://schemas.microsoft.com/office/drawing/2014/main" val="3706848419"/>
+                  </a:ext>
+                </a:extLst>
+              </a:tr>
+              <a:tr h="370840">
+                <a:tc>
+                  <a:txBody>
+                    <a:bodyPr/>
+                    <a:lstStyle/>
+                    <a:p>
+                      <a:r>
+                        <a:rPr lang="en-GB" dirty="0"/>
+                        <a:t>Resource-efficient RAG for the Indian Lok Sabha dataset (2025)</a:t>
+                      </a:r>
+                      <a:endParaRPr lang="en-IN" dirty="0"/>
+                    </a:p>
+                  </a:txBody>
+                  <a:tcPr/>
+                </a:tc>
+                <a:tc>
+                  <a:txBody>
+                    <a:bodyPr/>
+                    <a:lstStyle/>
+                    <a:p>
+                      <a:r>
+                        <a:rPr lang="en-GB" dirty="0"/>
+                        <a:t>Demonstrates that RAG can effectively parse massive, unstructured Indian legislative archives to make them easily readable for the public.</a:t>
+                      </a:r>
+                      <a:endParaRPr lang="en-IN" dirty="0"/>
+                    </a:p>
+                  </a:txBody>
+                  <a:tcPr/>
+                </a:tc>
+                <a:extLst>
+                  <a:ext uri="{0D108BD9-81ED-4DB2-BD59-A6C34878D82A}">
+                    <a16:rowId xmlns:a16="http://schemas.microsoft.com/office/drawing/2014/main" val="412233372"/>
+                  </a:ext>
+                </a:extLst>
+              </a:tr>
+            </a:tbl>
+          </a:graphicData>
+        </a:graphic>
+      </p:graphicFrame>
       <p:sp>
         <p:nvSpPr>
-          <p:cNvPr id="4" name="TextBox 3">
+          <p:cNvPr id="6" name="TextBox 5">
             <a:extLst>
               <a:ext uri="{FF2B5EF4-FFF2-40B4-BE49-F238E27FC236}">
-                <a16:creationId xmlns:a16="http://schemas.microsoft.com/office/drawing/2014/main" id="{084F4041-8131-3536-FDDF-513CA3ABA637}"/>
+                <a16:creationId xmlns:a16="http://schemas.microsoft.com/office/drawing/2014/main" id="{FA5B25B6-A34E-8D66-09FC-ED9E491CFA73}"/>
               </a:ext>
             </a:extLst>
           </p:cNvPr>
@@ -5755,8 +6008,8 @@
         </p:nvSpPr>
         <p:spPr>
           <a:xfrm>
-            <a:off x="6093893" y="57036"/>
-            <a:ext cx="6098107" cy="646331"/>
+            <a:off x="2792361" y="57036"/>
+            <a:ext cx="9399640" cy="369332"/>
           </a:xfrm>
           <a:prstGeom prst="rect">
             <a:avLst/>
@@ -5771,16 +6024,13 @@
           <a:p>
             <a:pPr algn="r"/>
             <a:r>
-              <a:rPr lang="en-US" sz="1800" b="1" i="1" dirty="0">
+              <a:rPr lang="en-GB" b="1" i="1" dirty="0">
                 <a:solidFill>
                   <a:srgbClr val="FFFFFF"/>
                 </a:solidFill>
               </a:rPr>
-              <a:t>Project Title -  Calibri body 18</a:t>
-            </a:r>
-          </a:p>
-          <a:p>
-            <a:pPr algn="r"/>
+              <a:t>AccessGov: An AI-Powered Assistive Platform for Accessing and Navigating Government Services</a:t>
+            </a:r>
             <a:endParaRPr lang="en-US" dirty="0"/>
           </a:p>
         </p:txBody>
@@ -5788,7 +6038,7 @@
     </p:spTree>
     <p:extLst>
       <p:ext uri="{BB962C8B-B14F-4D97-AF65-F5344CB8AC3E}">
-        <p14:creationId xmlns:p14="http://schemas.microsoft.com/office/powerpoint/2010/main" val="860765087"/>
+        <p14:creationId xmlns:p14="http://schemas.microsoft.com/office/powerpoint/2010/main" val="918532415"/>
       </p:ext>
     </p:extLst>
   </p:cSld>
@@ -5807,186 +6057,6 @@
       </p:transition>
     </mc:Fallback>
   </mc:AlternateContent>
-  <p:timing>
-    <p:tnLst>
-      <p:par>
-        <p:cTn id="1" dur="indefinite" restart="never" nodeType="tmRoot">
-          <p:childTnLst>
-            <p:seq concurrent="1" nextAc="seek">
-              <p:cTn id="2" dur="indefinite" nodeType="mainSeq">
-                <p:childTnLst>
-                  <p:par>
-                    <p:cTn id="3" fill="hold">
-                      <p:stCondLst>
-                        <p:cond delay="indefinite"/>
-                      </p:stCondLst>
-                      <p:childTnLst>
-                        <p:par>
-                          <p:cTn id="4" fill="hold">
-                            <p:stCondLst>
-                              <p:cond delay="0"/>
-                            </p:stCondLst>
-                            <p:childTnLst>
-                              <p:par>
-                                <p:cTn id="5" presetID="1" presetClass="entr" presetSubtype="0" fill="hold" grpId="0" nodeType="clickEffect">
-                                  <p:stCondLst>
-                                    <p:cond delay="0"/>
-                                  </p:stCondLst>
-                                  <p:childTnLst>
-                                    <p:set>
-                                      <p:cBhvr>
-                                        <p:cTn id="6" dur="1" fill="hold">
-                                          <p:stCondLst>
-                                            <p:cond delay="0"/>
-                                          </p:stCondLst>
-                                        </p:cTn>
-                                        <p:tgtEl>
-                                          <p:spTgt spid="2">
-                                            <p:txEl>
-                                              <p:pRg st="0" end="0"/>
-                                            </p:txEl>
-                                          </p:spTgt>
-                                        </p:tgtEl>
-                                        <p:attrNameLst>
-                                          <p:attrName>style.visibility</p:attrName>
-                                        </p:attrNameLst>
-                                      </p:cBhvr>
-                                      <p:to>
-                                        <p:strVal val="visible"/>
-                                      </p:to>
-                                    </p:set>
-                                  </p:childTnLst>
-                                </p:cTn>
-                              </p:par>
-                            </p:childTnLst>
-                          </p:cTn>
-                        </p:par>
-                      </p:childTnLst>
-                    </p:cTn>
-                  </p:par>
-                  <p:par>
-                    <p:cTn id="7" fill="hold">
-                      <p:stCondLst>
-                        <p:cond delay="indefinite"/>
-                      </p:stCondLst>
-                      <p:childTnLst>
-                        <p:par>
-                          <p:cTn id="8" fill="hold">
-                            <p:stCondLst>
-                              <p:cond delay="0"/>
-                            </p:stCondLst>
-                            <p:childTnLst>
-                              <p:par>
-                                <p:cTn id="9" presetID="1" presetClass="entr" presetSubtype="0" fill="hold" grpId="0" nodeType="clickEffect">
-                                  <p:stCondLst>
-                                    <p:cond delay="0"/>
-                                  </p:stCondLst>
-                                  <p:childTnLst>
-                                    <p:set>
-                                      <p:cBhvr>
-                                        <p:cTn id="10" dur="1" fill="hold">
-                                          <p:stCondLst>
-                                            <p:cond delay="0"/>
-                                          </p:stCondLst>
-                                        </p:cTn>
-                                        <p:tgtEl>
-                                          <p:spTgt spid="2">
-                                            <p:txEl>
-                                              <p:pRg st="1" end="1"/>
-                                            </p:txEl>
-                                          </p:spTgt>
-                                        </p:tgtEl>
-                                        <p:attrNameLst>
-                                          <p:attrName>style.visibility</p:attrName>
-                                        </p:attrNameLst>
-                                      </p:cBhvr>
-                                      <p:to>
-                                        <p:strVal val="visible"/>
-                                      </p:to>
-                                    </p:set>
-                                  </p:childTnLst>
-                                </p:cTn>
-                              </p:par>
-                            </p:childTnLst>
-                          </p:cTn>
-                        </p:par>
-                      </p:childTnLst>
-                    </p:cTn>
-                  </p:par>
-                  <p:par>
-                    <p:cTn id="11" fill="hold">
-                      <p:stCondLst>
-                        <p:cond delay="indefinite"/>
-                      </p:stCondLst>
-                      <p:childTnLst>
-                        <p:par>
-                          <p:cTn id="12" fill="hold">
-                            <p:stCondLst>
-                              <p:cond delay="0"/>
-                            </p:stCondLst>
-                            <p:childTnLst>
-                              <p:par>
-                                <p:cTn id="13" presetID="1" presetClass="entr" presetSubtype="0" fill="hold" grpId="0" nodeType="clickEffect">
-                                  <p:stCondLst>
-                                    <p:cond delay="0"/>
-                                  </p:stCondLst>
-                                  <p:childTnLst>
-                                    <p:set>
-                                      <p:cBhvr>
-                                        <p:cTn id="14" dur="1" fill="hold">
-                                          <p:stCondLst>
-                                            <p:cond delay="0"/>
-                                          </p:stCondLst>
-                                        </p:cTn>
-                                        <p:tgtEl>
-                                          <p:spTgt spid="2">
-                                            <p:txEl>
-                                              <p:pRg st="2" end="2"/>
-                                            </p:txEl>
-                                          </p:spTgt>
-                                        </p:tgtEl>
-                                        <p:attrNameLst>
-                                          <p:attrName>style.visibility</p:attrName>
-                                        </p:attrNameLst>
-                                      </p:cBhvr>
-                                      <p:to>
-                                        <p:strVal val="visible"/>
-                                      </p:to>
-                                    </p:set>
-                                  </p:childTnLst>
-                                </p:cTn>
-                              </p:par>
-                            </p:childTnLst>
-                          </p:cTn>
-                        </p:par>
-                      </p:childTnLst>
-                    </p:cTn>
-                  </p:par>
-                </p:childTnLst>
-              </p:cTn>
-              <p:prevCondLst>
-                <p:cond evt="onPrev" delay="0">
-                  <p:tgtEl>
-                    <p:sldTgt/>
-                  </p:tgtEl>
-                </p:cond>
-              </p:prevCondLst>
-              <p:nextCondLst>
-                <p:cond evt="onNext" delay="0">
-                  <p:tgtEl>
-                    <p:sldTgt/>
-                  </p:tgtEl>
-                </p:cond>
-              </p:nextCondLst>
-            </p:seq>
-          </p:childTnLst>
-        </p:cTn>
-      </p:par>
-    </p:tnLst>
-    <p:bldLst>
-      <p:bldP spid="2" grpId="0" uiExpand="1" build="p"/>
-    </p:bldLst>
-  </p:timing>
 </p:sld>
 </file>
 
@@ -6031,64 +6101,90 @@
         </p:nvSpPr>
         <p:spPr>
           <a:xfrm>
-            <a:off x="255996" y="1271219"/>
-            <a:ext cx="10624338" cy="4142989"/>
+            <a:off x="255995" y="1271219"/>
+            <a:ext cx="11611539" cy="4142989"/>
           </a:xfrm>
         </p:spPr>
         <p:txBody>
           <a:bodyPr/>
           <a:lstStyle/>
           <a:p>
-            <a:pPr>
+            <a:pPr marL="0" indent="0">
               <a:lnSpc>
                 <a:spcPct val="100000"/>
               </a:lnSpc>
+              <a:buNone/>
             </a:pPr>
             <a:r>
-              <a:rPr lang="en-US" b="0" dirty="0">
+              <a:rPr lang="en-GB" b="0" dirty="0">
                 <a:solidFill>
                   <a:srgbClr val="5583D1"/>
                 </a:solidFill>
-                <a:latin typeface="+mn-lt"/>
+                <a:latin typeface="Calibri (Body)"/>
+                <a:ea typeface="Calibri" panose="020F0502020204030204" pitchFamily="34" charset="0"/>
               </a:rPr>
-              <a:t>Current systems lack AI-driven semantic search and contextual summarization. </a:t>
-            </a:r>
-          </a:p>
-          <a:p>
-            <a:pPr>
+              <a:t>Current e-governance systems rely on rigid searches and dense PDFs, creating significant accessibility barriers for citizens.</a:t>
+            </a:r>
+          </a:p>
+          <a:p>
+            <a:pPr marL="0" indent="0">
               <a:lnSpc>
                 <a:spcPct val="100000"/>
               </a:lnSpc>
+              <a:buNone/>
             </a:pPr>
             <a:r>
-              <a:rPr lang="en-US" b="0" dirty="0">
+              <a:rPr lang="en-GB" b="0" dirty="0">
                 <a:solidFill>
                   <a:srgbClr val="5583D1"/>
                 </a:solidFill>
-                <a:latin typeface="+mn-lt"/>
+                <a:latin typeface="Calibri (Body)"/>
+                <a:ea typeface="Calibri" panose="020F0502020204030204" pitchFamily="34" charset="0"/>
               </a:rPr>
-              <a:t>There is a proven gap in accessibility for citizens trying to understand procedural requirements. </a:t>
-            </a:r>
-          </a:p>
-          <a:p>
-            <a:pPr>
+              <a:t>Recent research (2025-2026) highlights a major shift toward Retrieval-Augmented Generation (RAG) to provide intuitive, conversational search capabilities for public services. </a:t>
+            </a:r>
+          </a:p>
+          <a:p>
+            <a:pPr marL="0" indent="0">
               <a:lnSpc>
                 <a:spcPct val="100000"/>
               </a:lnSpc>
+              <a:buNone/>
             </a:pPr>
             <a:r>
-              <a:rPr lang="en-US" b="0" dirty="0">
+              <a:rPr lang="en-GB" b="0" dirty="0">
                 <a:solidFill>
                   <a:srgbClr val="5583D1"/>
                 </a:solidFill>
-                <a:latin typeface="+mn-lt"/>
+                <a:latin typeface="Calibri (Body)"/>
+                <a:ea typeface="Calibri" panose="020F0502020204030204" pitchFamily="34" charset="0"/>
               </a:rPr>
-              <a:t>Combining Hybrid Retrieval (BM25 + dense retrieval) with Reranking (cross-encoder) significantly improves information accuracy over traditional search engines.</a:t>
+              <a:t>Because public sector accuracy is critical, studies strongly emphasize the need for robust hallucination mitigation and transparent source citations. </a:t>
+            </a:r>
+          </a:p>
+          <a:p>
+            <a:pPr marL="0" indent="0">
+              <a:lnSpc>
+                <a:spcPct val="100000"/>
+              </a:lnSpc>
+              <a:buNone/>
+            </a:pPr>
+            <a:r>
+              <a:rPr lang="en-GB" b="0" dirty="0">
+                <a:solidFill>
+                  <a:srgbClr val="5583D1"/>
+                </a:solidFill>
+                <a:latin typeface="Calibri (Body)"/>
+                <a:ea typeface="Calibri" panose="020F0502020204030204" pitchFamily="34" charset="0"/>
+              </a:rPr>
+              <a:t>AccessGov directly aligns with these findings by delivering an accessible interface powered by a highly verifiable, citation-backed RAG pipeline.</a:t>
             </a:r>
             <a:endParaRPr lang="en-US" b="0" dirty="0">
               <a:solidFill>
                 <a:srgbClr val="5583D1"/>
               </a:solidFill>
+              <a:latin typeface="Calibri (Body)"/>
+              <a:ea typeface="Calibri" panose="020F0502020204030204" pitchFamily="34" charset="0"/>
             </a:endParaRPr>
           </a:p>
         </p:txBody>
@@ -6205,10 +6301,10 @@
       </p:cxnSp>
       <p:sp>
         <p:nvSpPr>
-          <p:cNvPr id="4" name="TextBox 3">
+          <p:cNvPr id="7" name="TextBox 6">
             <a:extLst>
               <a:ext uri="{FF2B5EF4-FFF2-40B4-BE49-F238E27FC236}">
-                <a16:creationId xmlns:a16="http://schemas.microsoft.com/office/drawing/2014/main" id="{8EADF6DB-6CFE-DDC5-997C-E84EE1A9470D}"/>
+                <a16:creationId xmlns:a16="http://schemas.microsoft.com/office/drawing/2014/main" id="{13244C70-F5C8-803A-D19B-F1AF0F569128}"/>
               </a:ext>
             </a:extLst>
           </p:cNvPr>
@@ -6217,8 +6313,8 @@
         </p:nvSpPr>
         <p:spPr>
           <a:xfrm>
-            <a:off x="6093893" y="57036"/>
-            <a:ext cx="6098107" cy="646331"/>
+            <a:off x="2792361" y="57036"/>
+            <a:ext cx="9399640" cy="369332"/>
           </a:xfrm>
           <a:prstGeom prst="rect">
             <a:avLst/>
@@ -6233,16 +6329,13 @@
           <a:p>
             <a:pPr algn="r"/>
             <a:r>
-              <a:rPr lang="en-US" sz="1800" b="1" i="1" dirty="0">
+              <a:rPr lang="en-GB" b="1" i="1" dirty="0">
                 <a:solidFill>
                   <a:srgbClr val="FFFFFF"/>
                 </a:solidFill>
               </a:rPr>
-              <a:t>Project Title -  Calibri body 18</a:t>
-            </a:r>
-          </a:p>
-          <a:p>
-            <a:pPr algn="r"/>
+              <a:t>AccessGov: An AI-Powered Assistive Platform for Accessing and Navigating Government Services</a:t>
+            </a:r>
             <a:endParaRPr lang="en-US" dirty="0"/>
           </a:p>
         </p:txBody>
@@ -6424,6 +6517,55 @@
                       </p:childTnLst>
                     </p:cTn>
                   </p:par>
+                  <p:par>
+                    <p:cTn id="15" fill="hold">
+                      <p:stCondLst>
+                        <p:cond delay="indefinite"/>
+                      </p:stCondLst>
+                      <p:childTnLst>
+                        <p:par>
+                          <p:cTn id="16" fill="hold">
+                            <p:stCondLst>
+                              <p:cond delay="0"/>
+                            </p:stCondLst>
+                            <p:childTnLst>
+                              <p:par>
+                                <p:cTn id="17" presetID="1" presetClass="entr" presetSubtype="0" fill="hold" grpId="0" nodeType="clickEffect">
+                                  <p:stCondLst>
+                                    <p:cond delay="0"/>
+                                  </p:stCondLst>
+                                  <p:childTnLst>
+                                    <p:set>
+                                      <p:cBhvr>
+                                        <p:cTn id="18" dur="1" fill="hold">
+                                          <p:stCondLst>
+                                            <p:cond delay="0"/>
+                                          </p:stCondLst>
+                                        </p:cTn>
+                                        <p:tgtEl>
+                                          <p:spTgt spid="2">
+                                            <p:txEl>
+                                              <p:pRg st="3" end="3"/>
+                                            </p:txEl>
+                                          </p:spTgt>
+                                        </p:tgtEl>
+                                        <p:attrNameLst>
+                                          <p:attrName>style.visibility</p:attrName>
+                                        </p:attrNameLst>
+                                      </p:cBhvr>
+                                      <p:to>
+                                        <p:strVal val="visible"/>
+                                      </p:to>
+                                    </p:set>
+                                  </p:childTnLst>
+                                </p:cTn>
+                              </p:par>
+                            </p:childTnLst>
+                          </p:cTn>
+                        </p:par>
+                      </p:childTnLst>
+                    </p:cTn>
+                  </p:par>
                 </p:childTnLst>
               </p:cTn>
               <p:prevCondLst>
@@ -6766,10 +6908,10 @@
       </p:cxnSp>
       <p:sp>
         <p:nvSpPr>
-          <p:cNvPr id="4" name="TextBox 3">
+          <p:cNvPr id="7" name="TextBox 6">
             <a:extLst>
               <a:ext uri="{FF2B5EF4-FFF2-40B4-BE49-F238E27FC236}">
-                <a16:creationId xmlns:a16="http://schemas.microsoft.com/office/drawing/2014/main" id="{64F7A196-7B69-DD68-52A5-39CD9B799F7D}"/>
+                <a16:creationId xmlns:a16="http://schemas.microsoft.com/office/drawing/2014/main" id="{AC1C21AB-07C4-8B78-9502-BEA4D864F6BE}"/>
               </a:ext>
             </a:extLst>
           </p:cNvPr>
@@ -6778,8 +6920,8 @@
         </p:nvSpPr>
         <p:spPr>
           <a:xfrm>
-            <a:off x="6093893" y="57036"/>
-            <a:ext cx="6098107" cy="646331"/>
+            <a:off x="2792361" y="57036"/>
+            <a:ext cx="9399640" cy="369332"/>
           </a:xfrm>
           <a:prstGeom prst="rect">
             <a:avLst/>
@@ -6794,16 +6936,13 @@
           <a:p>
             <a:pPr algn="r"/>
             <a:r>
-              <a:rPr lang="en-US" sz="1800" b="1" i="1" dirty="0">
+              <a:rPr lang="en-GB" b="1" i="1" dirty="0">
                 <a:solidFill>
                   <a:srgbClr val="FFFFFF"/>
                 </a:solidFill>
               </a:rPr>
-              <a:t>Project Title -  Calibri body 18</a:t>
-            </a:r>
-          </a:p>
-          <a:p>
-            <a:pPr algn="r"/>
+              <a:t>AccessGov: An AI-Powered Assistive Platform for Accessing and Navigating Government Services</a:t>
+            </a:r>
             <a:endParaRPr lang="en-US" dirty="0"/>
           </a:p>
         </p:txBody>
@@ -7064,23 +7203,46 @@
               <a:buAutoNum type="arabicPeriod"/>
             </a:pPr>
             <a:r>
-              <a:rPr lang="en-US" dirty="0">
+              <a:rPr lang="en-GB" dirty="0">
                 <a:solidFill>
                   <a:srgbClr val="5583D1"/>
                 </a:solidFill>
                 <a:latin typeface="Calibri (Body)"/>
               </a:rPr>
-              <a:t>Module 1:</a:t>
-            </a:r>
-            <a:r>
-              <a:rPr lang="en-US" b="0" dirty="0">
+              <a:t>Module 1: </a:t>
+            </a:r>
+            <a:r>
+              <a:rPr lang="en-GB" b="0" dirty="0">
                 <a:solidFill>
                   <a:srgbClr val="5583D1"/>
                 </a:solidFill>
                 <a:latin typeface="Calibri (Body)"/>
               </a:rPr>
-              <a:t> Document Parsing and Knowledge Base Construction </a:t>
-            </a:r>
+              <a:t>Document Parsing and Knowledge Base Construction:</a:t>
+            </a:r>
+          </a:p>
+          <a:p>
+            <a:pPr marL="457200" lvl="1" indent="0">
+              <a:lnSpc>
+                <a:spcPct val="100000"/>
+              </a:lnSpc>
+              <a:buNone/>
+            </a:pPr>
+            <a:r>
+              <a:rPr lang="en-GB" dirty="0">
+                <a:solidFill>
+                  <a:srgbClr val="5583D1"/>
+                </a:solidFill>
+                <a:latin typeface="Calibri (Body)"/>
+              </a:rPr>
+              <a:t>Extracting unstructured text from official government PDFs and chunking the data to build a highly organized, searchable knowledge base.</a:t>
+            </a:r>
+            <a:endParaRPr lang="en-US" b="0" dirty="0">
+              <a:solidFill>
+                <a:srgbClr val="5583D1"/>
+              </a:solidFill>
+              <a:latin typeface="Calibri (Body)"/>
+            </a:endParaRPr>
           </a:p>
           <a:p>
             <a:pPr marL="514350" indent="-514350">
@@ -7097,7 +7259,7 @@
                 </a:solidFill>
                 <a:latin typeface="Calibri (Body)"/>
               </a:rPr>
-              <a:t>Module 2:</a:t>
+              <a:t>Module 2: </a:t>
             </a:r>
             <a:r>
               <a:rPr lang="en-US" b="0" dirty="0">
@@ -7106,8 +7268,31 @@
                 </a:solidFill>
                 <a:latin typeface="Calibri (Body)"/>
               </a:rPr>
-              <a:t> RAG Pipeline Setup (Retrieval &amp; Reranking) </a:t>
-            </a:r>
+              <a:t>RAG Pipeline Setup (Hybrid Retrieval &amp; Reranking) </a:t>
+            </a:r>
+          </a:p>
+          <a:p>
+            <a:pPr marL="457200" lvl="1" indent="0">
+              <a:lnSpc>
+                <a:spcPct val="100000"/>
+              </a:lnSpc>
+              <a:buNone/>
+            </a:pPr>
+            <a:r>
+              <a:rPr lang="en-GB" dirty="0">
+                <a:solidFill>
+                  <a:srgbClr val="5583D1"/>
+                </a:solidFill>
+                <a:latin typeface="Calibri (Body)"/>
+              </a:rPr>
+              <a:t>Implementing a hybrid retrieval system with vector databases and reranking to fetch the most accurate information, then synthesizing it into natural language using an LLM.</a:t>
+            </a:r>
+            <a:endParaRPr lang="en-US" b="0" dirty="0">
+              <a:solidFill>
+                <a:srgbClr val="5583D1"/>
+              </a:solidFill>
+              <a:latin typeface="Calibri (Body)"/>
+            </a:endParaRPr>
           </a:p>
           <a:p>
             <a:pPr marL="514350" indent="-514350">
@@ -7133,8 +7318,31 @@
                 </a:solidFill>
                 <a:latin typeface="Calibri (Body)"/>
               </a:rPr>
-              <a:t> API Development and Frontend Integration</a:t>
-            </a:r>
+              <a:t> API Development &amp; Accessibility-Driven UI</a:t>
+            </a:r>
+          </a:p>
+          <a:p>
+            <a:pPr marL="457200" lvl="1" indent="0">
+              <a:lnSpc>
+                <a:spcPct val="100000"/>
+              </a:lnSpc>
+              <a:buNone/>
+            </a:pPr>
+            <a:r>
+              <a:rPr lang="en-GB" dirty="0">
+                <a:solidFill>
+                  <a:srgbClr val="5583D1"/>
+                </a:solidFill>
+                <a:latin typeface="Calibri (Body)"/>
+              </a:rPr>
+              <a:t>Building a robust backend API and an accessible frontend interface that features jargon-simplification (ELI5 mode), text-to-speech placeholders, and interactive form wizards for citizens.</a:t>
+            </a:r>
+            <a:endParaRPr lang="en-US" b="0" dirty="0">
+              <a:solidFill>
+                <a:srgbClr val="5583D1"/>
+              </a:solidFill>
+              <a:latin typeface="Calibri (Body)"/>
+            </a:endParaRPr>
           </a:p>
         </p:txBody>
       </p:sp>
@@ -7250,10 +7458,10 @@
       </p:cxnSp>
       <p:sp>
         <p:nvSpPr>
-          <p:cNvPr id="4" name="TextBox 3">
+          <p:cNvPr id="7" name="TextBox 6">
             <a:extLst>
               <a:ext uri="{FF2B5EF4-FFF2-40B4-BE49-F238E27FC236}">
-                <a16:creationId xmlns:a16="http://schemas.microsoft.com/office/drawing/2014/main" id="{5D4A0452-2CB8-E4C6-FAC7-ECD109C50CE1}"/>
+                <a16:creationId xmlns:a16="http://schemas.microsoft.com/office/drawing/2014/main" id="{180D0C5E-FAD5-8AD3-7A71-4993929CCD06}"/>
               </a:ext>
             </a:extLst>
           </p:cNvPr>
@@ -7262,8 +7470,8 @@
         </p:nvSpPr>
         <p:spPr>
           <a:xfrm>
-            <a:off x="6093893" y="57036"/>
-            <a:ext cx="6098107" cy="646331"/>
+            <a:off x="2792361" y="57036"/>
+            <a:ext cx="9399640" cy="369332"/>
           </a:xfrm>
           <a:prstGeom prst="rect">
             <a:avLst/>
@@ -7278,16 +7486,13 @@
           <a:p>
             <a:pPr algn="r"/>
             <a:r>
-              <a:rPr lang="en-US" sz="1800" b="1" i="1" dirty="0">
+              <a:rPr lang="en-GB" b="1" i="1" dirty="0">
                 <a:solidFill>
                   <a:srgbClr val="FFFFFF"/>
                 </a:solidFill>
               </a:rPr>
-              <a:t>Project Title -  Calibri body 18</a:t>
-            </a:r>
-          </a:p>
-          <a:p>
-            <a:pPr algn="r"/>
+              <a:t>AccessGov: An AI-Powered Assistive Platform for Accessing and Navigating Government Services</a:t>
+            </a:r>
             <a:endParaRPr lang="en-US" dirty="0"/>
           </a:p>
         </p:txBody>
@@ -7365,33 +7570,15 @@
                                   </p:childTnLst>
                                 </p:cTn>
                               </p:par>
-                            </p:childTnLst>
-                          </p:cTn>
-                        </p:par>
-                      </p:childTnLst>
-                    </p:cTn>
-                  </p:par>
-                  <p:par>
-                    <p:cTn id="7" fill="hold">
-                      <p:stCondLst>
-                        <p:cond delay="indefinite"/>
-                      </p:stCondLst>
-                      <p:childTnLst>
-                        <p:par>
-                          <p:cTn id="8" fill="hold">
-                            <p:stCondLst>
-                              <p:cond delay="0"/>
-                            </p:stCondLst>
-                            <p:childTnLst>
                               <p:par>
-                                <p:cTn id="9" presetID="1" presetClass="entr" presetSubtype="0" fill="hold" grpId="0" nodeType="clickEffect">
+                                <p:cTn id="7" presetID="1" presetClass="entr" presetSubtype="0" fill="hold" grpId="0" nodeType="withEffect">
                                   <p:stCondLst>
                                     <p:cond delay="0"/>
                                   </p:stCondLst>
                                   <p:childTnLst>
                                     <p:set>
                                       <p:cBhvr>
-                                        <p:cTn id="10" dur="1" fill="hold">
+                                        <p:cTn id="8" dur="1" fill="hold">
                                           <p:stCondLst>
                                             <p:cond delay="0"/>
                                           </p:stCondLst>
@@ -7421,19 +7608,50 @@
                     </p:cTn>
                   </p:par>
                   <p:par>
-                    <p:cTn id="11" fill="hold">
+                    <p:cTn id="9" fill="hold">
                       <p:stCondLst>
                         <p:cond delay="indefinite"/>
                       </p:stCondLst>
                       <p:childTnLst>
                         <p:par>
-                          <p:cTn id="12" fill="hold">
+                          <p:cTn id="10" fill="hold">
                             <p:stCondLst>
                               <p:cond delay="0"/>
                             </p:stCondLst>
                             <p:childTnLst>
                               <p:par>
-                                <p:cTn id="13" presetID="1" presetClass="entr" presetSubtype="0" fill="hold" grpId="0" nodeType="clickEffect">
+                                <p:cTn id="11" presetID="1" presetClass="entr" presetSubtype="0" fill="hold" grpId="0" nodeType="clickEffect">
+                                  <p:stCondLst>
+                                    <p:cond delay="0"/>
+                                  </p:stCondLst>
+                                  <p:childTnLst>
+                                    <p:set>
+                                      <p:cBhvr>
+                                        <p:cTn id="12" dur="1" fill="hold">
+                                          <p:stCondLst>
+                                            <p:cond delay="0"/>
+                                          </p:stCondLst>
+                                        </p:cTn>
+                                        <p:tgtEl>
+                                          <p:spTgt spid="2">
+                                            <p:txEl>
+                                              <p:pRg st="2" end="2"/>
+                                            </p:txEl>
+                                          </p:spTgt>
+                                        </p:tgtEl>
+                                        <p:attrNameLst>
+                                          <p:attrName>style.visibility</p:attrName>
+                                        </p:attrNameLst>
+                                      </p:cBhvr>
+                                      <p:to>
+                                        <p:strVal val="visible"/>
+                                      </p:to>
+                                    </p:set>
+                                  </p:childTnLst>
+                                </p:cTn>
+                              </p:par>
+                              <p:par>
+                                <p:cTn id="13" presetID="1" presetClass="entr" presetSubtype="0" fill="hold" grpId="0" nodeType="withEffect">
                                   <p:stCondLst>
                                     <p:cond delay="0"/>
                                   </p:stCondLst>
@@ -7448,7 +7666,87 @@
                                         <p:tgtEl>
                                           <p:spTgt spid="2">
                                             <p:txEl>
-                                              <p:pRg st="2" end="2"/>
+                                              <p:pRg st="3" end="3"/>
+                                            </p:txEl>
+                                          </p:spTgt>
+                                        </p:tgtEl>
+                                        <p:attrNameLst>
+                                          <p:attrName>style.visibility</p:attrName>
+                                        </p:attrNameLst>
+                                      </p:cBhvr>
+                                      <p:to>
+                                        <p:strVal val="visible"/>
+                                      </p:to>
+                                    </p:set>
+                                  </p:childTnLst>
+                                </p:cTn>
+                              </p:par>
+                            </p:childTnLst>
+                          </p:cTn>
+                        </p:par>
+                      </p:childTnLst>
+                    </p:cTn>
+                  </p:par>
+                  <p:par>
+                    <p:cTn id="15" fill="hold">
+                      <p:stCondLst>
+                        <p:cond delay="indefinite"/>
+                      </p:stCondLst>
+                      <p:childTnLst>
+                        <p:par>
+                          <p:cTn id="16" fill="hold">
+                            <p:stCondLst>
+                              <p:cond delay="0"/>
+                            </p:stCondLst>
+                            <p:childTnLst>
+                              <p:par>
+                                <p:cTn id="17" presetID="1" presetClass="entr" presetSubtype="0" fill="hold" grpId="0" nodeType="clickEffect">
+                                  <p:stCondLst>
+                                    <p:cond delay="0"/>
+                                  </p:stCondLst>
+                                  <p:childTnLst>
+                                    <p:set>
+                                      <p:cBhvr>
+                                        <p:cTn id="18" dur="1" fill="hold">
+                                          <p:stCondLst>
+                                            <p:cond delay="0"/>
+                                          </p:stCondLst>
+                                        </p:cTn>
+                                        <p:tgtEl>
+                                          <p:spTgt spid="2">
+                                            <p:txEl>
+                                              <p:pRg st="4" end="4"/>
+                                            </p:txEl>
+                                          </p:spTgt>
+                                        </p:tgtEl>
+                                        <p:attrNameLst>
+                                          <p:attrName>style.visibility</p:attrName>
+                                        </p:attrNameLst>
+                                      </p:cBhvr>
+                                      <p:to>
+                                        <p:strVal val="visible"/>
+                                      </p:to>
+                                    </p:set>
+                                  </p:childTnLst>
+                                </p:cTn>
+                              </p:par>
+                              <p:par>
+                                <p:cTn id="19" presetID="1" presetClass="entr" presetSubtype="0" fill="hold" grpId="0" nodeType="withEffect">
+                                  <p:stCondLst>
+                                    <p:cond delay="0"/>
+                                  </p:stCondLst>
+                                  <p:childTnLst>
+                                    <p:set>
+                                      <p:cBhvr>
+                                        <p:cTn id="20" dur="1" fill="hold">
+                                          <p:stCondLst>
+                                            <p:cond delay="0"/>
+                                          </p:stCondLst>
+                                        </p:cTn>
+                                        <p:tgtEl>
+                                          <p:spTgt spid="2">
+                                            <p:txEl>
+                                              <p:pRg st="5" end="5"/>
                                             </p:txEl>
                                           </p:spTgt>
                                         </p:tgtEl>
@@ -7561,7 +7859,7 @@
                   <a:srgbClr val="1C3898"/>
                 </a:solidFill>
               </a:rPr>
-              <a:t>Extracting textual data from official government PDFs using PyMuPDF and python-docx. </a:t>
+              <a:t>Extracting unstructured textual data from official government PDFs using PyMuPDF. </a:t>
             </a:r>
           </a:p>
           <a:p>
@@ -7572,39 +7870,18 @@
                   <a:srgbClr val="1C3898"/>
                 </a:solidFill>
               </a:rPr>
-              <a:t>Chunking text using </a:t>
-            </a:r>
-            <a:r>
-              <a:rPr lang="en-US" sz="2800" dirty="0" err="1">
+              <a:t>Chunking text effectively using Lang Chain's RecursiveCharacterTextSplitter. </a:t>
+            </a:r>
+          </a:p>
+          <a:p>
+            <a:pPr lvl="1"/>
+            <a:r>
+              <a:rPr lang="en-US" sz="2800" dirty="0">
                 <a:solidFill>
                   <a:srgbClr val="1C3898"/>
                 </a:solidFill>
               </a:rPr>
-              <a:t>LangChain's</a:t>
-            </a:r>
-            <a:r>
-              <a:rPr lang="en-US" sz="2800" dirty="0">
-                <a:solidFill>
-                  <a:srgbClr val="1C3898"/>
-                </a:solidFill>
-              </a:rPr>
-              <a:t> </a:t>
-            </a:r>
-            <a:r>
-              <a:rPr lang="en-US" sz="2800" dirty="0" err="1">
-                <a:solidFill>
-                  <a:srgbClr val="1C3898"/>
-                </a:solidFill>
-              </a:rPr>
-              <a:t>RecursiveCharacterTextSplitter</a:t>
-            </a:r>
-            <a:r>
-              <a:rPr lang="en-US" sz="2800" dirty="0">
-                <a:solidFill>
-                  <a:srgbClr val="1C3898"/>
-                </a:solidFill>
-              </a:rPr>
-              <a:t>. Generating embeddings and storing them in </a:t>
+              <a:t>Generating embeddings and storing them in </a:t>
             </a:r>
             <a:r>
               <a:rPr lang="en-US" sz="2800" dirty="0" err="1">
@@ -7620,34 +7897,7 @@
                   <a:srgbClr val="1C3898"/>
                 </a:solidFill>
               </a:rPr>
-              <a:t>. </a:t>
-            </a:r>
-          </a:p>
-          <a:p>
-            <a:pPr lvl="1"/>
-            <a:r>
-              <a:rPr lang="en-US" sz="2800" dirty="0">
-                <a:solidFill>
-                  <a:srgbClr val="1C3898"/>
-                </a:solidFill>
-              </a:rPr>
-              <a:t>Establishing </a:t>
-            </a:r>
-            <a:r>
-              <a:rPr lang="en-US" sz="2800" dirty="0" err="1">
-                <a:solidFill>
-                  <a:srgbClr val="1C3898"/>
-                </a:solidFill>
-              </a:rPr>
-              <a:t>MinIO</a:t>
-            </a:r>
-            <a:r>
-              <a:rPr lang="en-US" sz="2800" dirty="0">
-                <a:solidFill>
-                  <a:srgbClr val="1C3898"/>
-                </a:solidFill>
-              </a:rPr>
-              <a:t> for document storage and PostgreSQL for metadata.</a:t>
+              <a:t> for fast semantic search.</a:t>
             </a:r>
           </a:p>
         </p:txBody>
@@ -7768,10 +8018,10 @@
       </p:cxnSp>
       <p:sp>
         <p:nvSpPr>
-          <p:cNvPr id="6" name="TextBox 5">
+          <p:cNvPr id="7" name="TextBox 6">
             <a:extLst>
               <a:ext uri="{FF2B5EF4-FFF2-40B4-BE49-F238E27FC236}">
-                <a16:creationId xmlns:a16="http://schemas.microsoft.com/office/drawing/2014/main" id="{65221164-7940-3B34-A613-28A74A63E0F7}"/>
+                <a16:creationId xmlns:a16="http://schemas.microsoft.com/office/drawing/2014/main" id="{450A6363-C8D2-06AF-FD71-D5B40487A089}"/>
               </a:ext>
             </a:extLst>
           </p:cNvPr>
@@ -7780,8 +8030,8 @@
         </p:nvSpPr>
         <p:spPr>
           <a:xfrm>
-            <a:off x="6093893" y="57036"/>
-            <a:ext cx="6098107" cy="646331"/>
+            <a:off x="2792361" y="57036"/>
+            <a:ext cx="9399640" cy="369332"/>
           </a:xfrm>
           <a:prstGeom prst="rect">
             <a:avLst/>
@@ -7796,16 +8046,13 @@
           <a:p>
             <a:pPr algn="r"/>
             <a:r>
-              <a:rPr lang="en-US" b="1" i="1" dirty="0">
+              <a:rPr lang="en-GB" b="1" i="1" dirty="0">
                 <a:solidFill>
                   <a:srgbClr val="FFFFFF"/>
                 </a:solidFill>
               </a:rPr>
-              <a:t>Project Title -  Calibri body 18</a:t>
-            </a:r>
-          </a:p>
-          <a:p>
-            <a:pPr algn="r"/>
+              <a:t>AccessGov: An AI-Powered Assistive Platform for Accessing and Navigating Government Services</a:t>
+            </a:r>
             <a:endParaRPr lang="en-US" dirty="0"/>
           </a:p>
         </p:txBody>
@@ -7917,99 +8164,6 @@
                                           <p:spTgt spid="2">
                                             <p:txEl>
                                               <p:pRg st="0" end="0"/>
-                                            </p:txEl>
-                                          </p:spTgt>
-                                        </p:tgtEl>
-                                        <p:attrNameLst>
-                                          <p:attrName>style.visibility</p:attrName>
-                                        </p:attrNameLst>
-                                      </p:cBhvr>
-                                      <p:to>
-                                        <p:strVal val="visible"/>
-                                      </p:to>
-                                    </p:set>
-                                  </p:childTnLst>
-                                </p:cTn>
-                              </p:par>
-                              <p:par>
-                                <p:cTn id="11" presetID="1" presetClass="entr" presetSubtype="0" fill="hold" grpId="0" nodeType="withEffect">
-                                  <p:stCondLst>
-                                    <p:cond delay="0"/>
-                                  </p:stCondLst>
-                                  <p:childTnLst>
-                                    <p:set>
-                                      <p:cBhvr>
-                                        <p:cTn id="12" dur="1" fill="hold">
-                                          <p:stCondLst>
-                                            <p:cond delay="0"/>
-                                          </p:stCondLst>
-                                        </p:cTn>
-                                        <p:tgtEl>
-                                          <p:spTgt spid="2">
-                                            <p:txEl>
-                                              <p:pRg st="1" end="1"/>
-                                            </p:txEl>
-                                          </p:spTgt>
-                                        </p:tgtEl>
-                                        <p:attrNameLst>
-                                          <p:attrName>style.visibility</p:attrName>
-                                        </p:attrNameLst>
-                                      </p:cBhvr>
-                                      <p:to>
-                                        <p:strVal val="visible"/>
-                                      </p:to>
-                                    </p:set>
-                                  </p:childTnLst>
-                                </p:cTn>
-                              </p:par>
-                              <p:par>
-                                <p:cTn id="13" presetID="1" presetClass="entr" presetSubtype="0" fill="hold" grpId="0" nodeType="withEffect">
-                                  <p:stCondLst>
-                                    <p:cond delay="0"/>
-                                  </p:stCondLst>
-                                  <p:childTnLst>
-                                    <p:set>
-                                      <p:cBhvr>
-                                        <p:cTn id="14" dur="1" fill="hold">
-                                          <p:stCondLst>
-                                            <p:cond delay="0"/>
-                                          </p:stCondLst>
-                                        </p:cTn>
-                                        <p:tgtEl>
-                                          <p:spTgt spid="2">
-                                            <p:txEl>
-                                              <p:pRg st="2" end="2"/>
-                                            </p:txEl>
-                                          </p:spTgt>
-                                        </p:tgtEl>
-                                        <p:attrNameLst>
-                                          <p:attrName>style.visibility</p:attrName>
-                                        </p:attrNameLst>
-                                      </p:cBhvr>
-                                      <p:to>
-                                        <p:strVal val="visible"/>
-                                      </p:to>
-                                    </p:set>
-                                  </p:childTnLst>
-                                </p:cTn>
-                              </p:par>
-                              <p:par>
-                                <p:cTn id="15" presetID="1" presetClass="entr" presetSubtype="0" fill="hold" grpId="0" nodeType="withEffect">
-                                  <p:stCondLst>
-                                    <p:cond delay="0"/>
-                                  </p:stCondLst>
-                                  <p:childTnLst>
-                                    <p:set>
-                                      <p:cBhvr>
-                                        <p:cTn id="16" dur="1" fill="hold">
-                                          <p:stCondLst>
-                                            <p:cond delay="0"/>
-                                          </p:stCondLst>
-                                        </p:cTn>
-                                        <p:tgtEl>
-                                          <p:spTgt spid="2">
-                                            <p:txEl>
-                                              <p:pRg st="3" end="3"/>
                                             </p:txEl>
                                           </p:spTgt>
                                         </p:tgtEl>

</xml_diff>

<commit_message>
docs: update VIT-Chennai review presentation for project Rahi
</commit_message>
<xml_diff>
--- a/T9998_VIT-Chennai_Rahi_Sanxipt_Mehta_Review1.pptx
+++ b/T9998_VIT-Chennai_Rahi_Sanxipt_Mehta_Review1.pptx
@@ -3552,7 +3552,7 @@
         <p:spPr>
           <a:xfrm>
             <a:off x="180236" y="1659822"/>
-            <a:ext cx="11428184" cy="4062651"/>
+            <a:ext cx="11428184" cy="2769989"/>
           </a:xfrm>
           <a:prstGeom prst="rect">
             <a:avLst/>
@@ -3573,6 +3573,7 @@
                 <a:solidFill>
                   <a:prstClr val="white"/>
                 </a:solidFill>
+                <a:latin typeface="Calibri (Body)"/>
                 <a:cs typeface="Calibri" panose="020F0502020204030204" pitchFamily="34" charset="0"/>
               </a:rPr>
               <a:t>AccessGov - </a:t>
@@ -3582,6 +3583,7 @@
                 <a:solidFill>
                   <a:prstClr val="white"/>
                 </a:solidFill>
+                <a:latin typeface="Calibri (Body)"/>
                 <a:cs typeface="Calibri" panose="020F0502020204030204" pitchFamily="34" charset="0"/>
               </a:rPr>
               <a:t>An AI-Powered Assistive Platform for Accessing and Navigating Government Services</a:t>
@@ -3590,6 +3592,7 @@
               <a:solidFill>
                 <a:prstClr val="white"/>
               </a:solidFill>
+              <a:latin typeface="Calibri (Body)"/>
               <a:cs typeface="Calibri" panose="020F0502020204030204" pitchFamily="34" charset="0"/>
             </a:endParaRPr>
           </a:p>
@@ -3607,8 +3610,7 @@
               <a:effectLst/>
               <a:uLnTx/>
               <a:uFillTx/>
-              <a:latin typeface="Frutiger 45 bold"/>
-              <a:ea typeface="+mn-ea"/>
+              <a:latin typeface="Calibri (Body)"/>
               <a:cs typeface="Calibri" panose="020F0502020204030204" pitchFamily="34" charset="0"/>
             </a:endParaRPr>
           </a:p>
@@ -3621,6 +3623,7 @@
                 <a:solidFill>
                   <a:prstClr val="white"/>
                 </a:solidFill>
+                <a:latin typeface="Calibri (Body)"/>
                 <a:cs typeface="Calibri" panose="020F0502020204030204" pitchFamily="34" charset="0"/>
               </a:rPr>
               <a:t>Rahi Sanxipt Mehta</a:t>
@@ -3630,30 +3633,21 @@
             <a:pPr lvl="0" algn="ctr">
               <a:defRPr/>
             </a:pPr>
-            <a:endParaRPr lang="en-US" sz="5400" b="1" dirty="0">
+            <a:r>
+              <a:rPr lang="en-US" sz="2400" b="1">
+                <a:solidFill>
+                  <a:prstClr val="white"/>
+                </a:solidFill>
+                <a:latin typeface="Calibri (Body)"/>
+                <a:cs typeface="Calibri" panose="020F0502020204030204" pitchFamily="34" charset="0"/>
+              </a:rPr>
+              <a:t>VIT Chennai</a:t>
+            </a:r>
+            <a:endParaRPr lang="en-US" sz="2400" b="1" dirty="0">
               <a:solidFill>
                 <a:prstClr val="white"/>
               </a:solidFill>
-              <a:latin typeface="Frutiger 45 bold"/>
-              <a:cs typeface="Calibri" panose="020F0502020204030204" pitchFamily="34" charset="0"/>
-            </a:endParaRPr>
-          </a:p>
-          <a:p>
-            <a:pPr lvl="0" algn="ctr">
-              <a:defRPr/>
-            </a:pPr>
-            <a:endParaRPr kumimoji="0" lang="en-US" sz="5400" b="1" i="0" u="none" strike="noStrike" kern="1200" cap="none" spc="0" normalizeH="0" baseline="0" noProof="0" dirty="0">
-              <a:ln>
-                <a:noFill/>
-              </a:ln>
-              <a:solidFill>
-                <a:prstClr val="white"/>
-              </a:solidFill>
-              <a:effectLst/>
-              <a:uLnTx/>
-              <a:uFillTx/>
-              <a:latin typeface="Frutiger 45 bold"/>
-              <a:ea typeface="+mn-ea"/>
+              <a:latin typeface="Calibri (Body)"/>
               <a:cs typeface="Calibri" panose="020F0502020204030204" pitchFamily="34" charset="0"/>
             </a:endParaRPr>
           </a:p>

</xml_diff>